<commit_message>
Put the schema we discussed in lab into a markdonw file
</commit_message>
<xml_diff>
--- a/CommUnity Technical Presentation.pptx
+++ b/CommUnity Technical Presentation.pptx
@@ -3945,15 +3945,7 @@
                   <a:schemeClr val="tx1"/>
                 </a:solidFill>
               </a:rPr>
-              <a:t>KE </a:t>
-            </a:r>
-            <a:r>
-              <a:rPr lang="en-US" sz="2000" u="sng" dirty="0" err="1">
-                <a:solidFill>
-                  <a:schemeClr val="tx1"/>
-                </a:solidFill>
-              </a:rPr>
-              <a:t>Apartements</a:t>
+              <a:t>KE Apartments</a:t>
             </a:r>
             <a:endParaRPr lang="en-US" u="sng" dirty="0">
               <a:solidFill>
@@ -4560,7 +4552,7 @@
         </p:nvSpPr>
         <p:spPr>
           <a:xfrm>
-            <a:off x="1600200" y="1825625"/>
+            <a:off x="1595966" y="1554692"/>
             <a:ext cx="9000067" cy="4351338"/>
           </a:xfrm>
           <a:ln>
@@ -4592,7 +4584,32 @@
             </a:r>
             <a:r>
               <a:rPr lang="en-US" sz="3200" dirty="0"/>
-              <a:t>, users can reach out to their own communities and share advice. The app is designed for Calvin communities, but the concept could be expanded.</a:t>
+              <a:t>, users can reach out to their own communities to </a:t>
+            </a:r>
+            <a:r>
+              <a:rPr lang="en-US" sz="3200" b="1" dirty="0"/>
+              <a:t>ask</a:t>
+            </a:r>
+            <a:r>
+              <a:rPr lang="en-US" sz="3200" dirty="0"/>
+              <a:t> and </a:t>
+            </a:r>
+            <a:r>
+              <a:rPr lang="en-US" sz="3200" b="1" dirty="0"/>
+              <a:t>answer </a:t>
+            </a:r>
+            <a:r>
+              <a:rPr lang="en-US" sz="3200" dirty="0"/>
+              <a:t>questions. The app is designed for Calvin communities, but the concept could be expanded.</a:t>
+            </a:r>
+          </a:p>
+          <a:p>
+            <a:pPr marL="0" indent="0" algn="ctr">
+              <a:buNone/>
+            </a:pPr>
+            <a:r>
+              <a:rPr lang="en-US" sz="3200" dirty="0"/>
+              <a:t>The app prevents anonymous posts to encourage genuine community.</a:t>
             </a:r>
           </a:p>
         </p:txBody>
@@ -4646,7 +4663,7 @@
         <p:spPr>
           <a:xfrm>
             <a:off x="839787" y="457200"/>
-            <a:ext cx="5256211" cy="1600200"/>
+            <a:ext cx="5256211" cy="855133"/>
           </a:xfrm>
         </p:spPr>
         <p:txBody>
@@ -4657,7 +4674,7 @@
           <a:p>
             <a:r>
               <a:rPr lang="en-US" sz="4000" dirty="0"/>
-              <a:t>Here We Demonstrate:</a:t>
+              <a:t>Demonstration Notes</a:t>
             </a:r>
           </a:p>
         </p:txBody>
@@ -4692,6 +4709,11 @@
           <a:prstGeom prst="rect">
             <a:avLst/>
           </a:prstGeom>
+          <a:ln w="28575">
+            <a:solidFill>
+              <a:schemeClr val="tx1"/>
+            </a:solidFill>
+          </a:ln>
         </p:spPr>
       </p:pic>
       <p:sp>
@@ -4712,8 +4734,8 @@
         </p:nvSpPr>
         <p:spPr>
           <a:xfrm>
-            <a:off x="839788" y="2057400"/>
-            <a:ext cx="5256212" cy="3811588"/>
+            <a:off x="839787" y="1371600"/>
+            <a:ext cx="5882745" cy="4497388"/>
           </a:xfrm>
         </p:spPr>
         <p:txBody>
@@ -4727,8 +4749,58 @@
               <a:buChar char="•"/>
             </a:pPr>
             <a:r>
-              <a:rPr lang="en-US" sz="1800" dirty="0"/>
-              <a:t>Some key requirements and user stories</a:t>
+              <a:rPr lang="en-US" sz="2400" dirty="0"/>
+              <a:t>Key functional requirements include:</a:t>
+            </a:r>
+          </a:p>
+          <a:p>
+            <a:pPr marL="742950" lvl="1" indent="-285750">
+              <a:buFont typeface="Arial" panose="020B0604020202020204" pitchFamily="34" charset="0"/>
+              <a:buChar char="•"/>
+            </a:pPr>
+            <a:r>
+              <a:rPr lang="en-US" sz="2000" dirty="0"/>
+              <a:t>Users search existing questions</a:t>
+            </a:r>
+          </a:p>
+          <a:p>
+            <a:pPr marL="742950" lvl="1" indent="-285750">
+              <a:buFont typeface="Arial" panose="020B0604020202020204" pitchFamily="34" charset="0"/>
+              <a:buChar char="•"/>
+            </a:pPr>
+            <a:r>
+              <a:rPr lang="en-US" sz="2000" dirty="0"/>
+              <a:t>Users ask questions</a:t>
+            </a:r>
+          </a:p>
+          <a:p>
+            <a:pPr marL="742950" lvl="1" indent="-285750">
+              <a:buFont typeface="Arial" panose="020B0604020202020204" pitchFamily="34" charset="0"/>
+              <a:buChar char="•"/>
+            </a:pPr>
+            <a:r>
+              <a:rPr lang="en-US" sz="2000" dirty="0"/>
+              <a:t>Users check their own past questions</a:t>
+            </a:r>
+          </a:p>
+          <a:p>
+            <a:pPr marL="742950" lvl="1" indent="-285750">
+              <a:buFont typeface="Arial" panose="020B0604020202020204" pitchFamily="34" charset="0"/>
+              <a:buChar char="•"/>
+            </a:pPr>
+            <a:r>
+              <a:rPr lang="en-US" sz="2000" dirty="0"/>
+              <a:t>Users reply to questions</a:t>
+            </a:r>
+          </a:p>
+          <a:p>
+            <a:pPr marL="742950" lvl="1" indent="-285750">
+              <a:buFont typeface="Arial" panose="020B0604020202020204" pitchFamily="34" charset="0"/>
+              <a:buChar char="•"/>
+            </a:pPr>
+            <a:r>
+              <a:rPr lang="en-US" sz="2000" dirty="0"/>
+              <a:t>Users log in</a:t>
             </a:r>
           </a:p>
           <a:p>
@@ -4737,8 +4809,28 @@
               <a:buChar char="•"/>
             </a:pPr>
             <a:r>
+              <a:rPr lang="en-US" sz="2400" dirty="0"/>
+              <a:t>Key UI design features include</a:t>
+            </a:r>
+          </a:p>
+          <a:p>
+            <a:pPr marL="742950" lvl="1" indent="-285750">
+              <a:buFont typeface="Arial" panose="020B0604020202020204" pitchFamily="34" charset="0"/>
+              <a:buChar char="•"/>
+            </a:pPr>
+            <a:r>
+              <a:rPr lang="en-US" sz="2000" dirty="0"/>
+              <a:t>Search tags</a:t>
+            </a:r>
+          </a:p>
+          <a:p>
+            <a:pPr marL="742950" lvl="1" indent="-285750">
+              <a:buFont typeface="Arial" panose="020B0604020202020204" pitchFamily="34" charset="0"/>
+              <a:buChar char="•"/>
+            </a:pPr>
+            <a:r>
               <a:rPr lang="en-US" sz="1800" dirty="0"/>
-              <a:t>Fundamental UI design features</a:t>
+              <a:t>“My posts” under “profile”</a:t>
             </a:r>
           </a:p>
         </p:txBody>
@@ -4913,8 +5005,8 @@
         </p:blipFill>
         <p:spPr>
           <a:xfrm>
-            <a:off x="4350171" y="1299134"/>
-            <a:ext cx="7250610" cy="4259732"/>
+            <a:off x="4216526" y="1299134"/>
+            <a:ext cx="7384255" cy="4259732"/>
           </a:xfrm>
           <a:prstGeom prst="rect">
             <a:avLst/>
@@ -4935,7 +5027,7 @@
 </file>
 
 <file path=ppt/slides/slide7.xml><?xml version="1.0" encoding="utf-8"?>
-<p:sld xmlns:a="http://schemas.openxmlformats.org/drawingml/2006/main" xmlns:r="http://schemas.openxmlformats.org/officeDocument/2006/relationships" xmlns:p="http://schemas.openxmlformats.org/presentationml/2006/main">
+<p:sld xmlns:a="http://schemas.openxmlformats.org/drawingml/2006/main" xmlns:r="http://schemas.openxmlformats.org/officeDocument/2006/relationships" xmlns:p="http://schemas.openxmlformats.org/presentationml/2006/main" show="0">
   <p:cSld>
     <p:spTree>
       <p:nvGrpSpPr>
@@ -5346,7 +5438,7 @@
           <a:p>
             <a:r>
               <a:rPr lang="en-US" dirty="0"/>
-              <a:t>Post reply page</a:t>
+              <a:t>Reply page</a:t>
             </a:r>
           </a:p>
           <a:p>
@@ -5757,6 +5849,23 @@
 </file>
 
 <file path=customXml/item1.xml><?xml version="1.0" encoding="utf-8"?>
+<?mso-contentType ?>
+<FormTemplates xmlns="http://schemas.microsoft.com/sharepoint/v3/contenttype/forms">
+  <Display>DocumentLibraryForm</Display>
+  <Edit>DocumentLibraryForm</Edit>
+  <New>DocumentLibraryForm</New>
+</FormTemplates>
+</file>
+
+<file path=customXml/item2.xml><?xml version="1.0" encoding="utf-8"?>
+<p:properties xmlns:p="http://schemas.microsoft.com/office/2006/metadata/properties" xmlns:xsi="http://www.w3.org/2001/XMLSchema-instance" xmlns:pc="http://schemas.microsoft.com/office/infopath/2007/PartnerControls">
+  <documentManagement>
+    <_activity xmlns="6283f531-c8c1-40fe-bb20-fcb69b65cda3" xsi:nil="true"/>
+  </documentManagement>
+</p:properties>
+</file>
+
+<file path=customXml/item3.xml><?xml version="1.0" encoding="utf-8"?>
 <ct:contentTypeSchema xmlns:ct="http://schemas.microsoft.com/office/2006/metadata/contentType" xmlns:ma="http://schemas.microsoft.com/office/2006/metadata/properties/metaAttributes" ct:_="" ma:_="" ma:contentTypeName="Document" ma:contentTypeID="0x01010042894265C9F55549B4E26363483874AC" ma:contentTypeVersion="14" ma:contentTypeDescription="Create a new document." ma:contentTypeScope="" ma:versionID="11062da2fdb1a3b5a4031c12d7a08efc">
   <xsd:schema xmlns:xsd="http://www.w3.org/2001/XMLSchema" xmlns:xs="http://www.w3.org/2001/XMLSchema" xmlns:p="http://schemas.microsoft.com/office/2006/metadata/properties" xmlns:ns3="6283f531-c8c1-40fe-bb20-fcb69b65cda3" xmlns:ns4="34dc7572-b32f-4f93-9661-b1209073c24a" targetNamespace="http://schemas.microsoft.com/office/2006/metadata/properties" ma:root="true" ma:fieldsID="227fd24f4cbe8aa968056a232328630f" ns3:_="" ns4:_="">
     <xsd:import namespace="6283f531-c8c1-40fe-bb20-fcb69b65cda3"/>
@@ -5983,38 +6092,10 @@
 </ct:contentTypeSchema>
 </file>
 
-<file path=customXml/item2.xml><?xml version="1.0" encoding="utf-8"?>
-<p:properties xmlns:p="http://schemas.microsoft.com/office/2006/metadata/properties" xmlns:xsi="http://www.w3.org/2001/XMLSchema-instance" xmlns:pc="http://schemas.microsoft.com/office/infopath/2007/PartnerControls">
-  <documentManagement>
-    <_activity xmlns="6283f531-c8c1-40fe-bb20-fcb69b65cda3" xsi:nil="true"/>
-  </documentManagement>
-</p:properties>
-</file>
-
-<file path=customXml/item3.xml><?xml version="1.0" encoding="utf-8"?>
-<?mso-contentType ?>
-<FormTemplates xmlns="http://schemas.microsoft.com/sharepoint/v3/contenttype/forms">
-  <Display>DocumentLibraryForm</Display>
-  <Edit>DocumentLibraryForm</Edit>
-  <New>DocumentLibraryForm</New>
-</FormTemplates>
-</file>
-
 <file path=customXml/itemProps1.xml><?xml version="1.0" encoding="utf-8"?>
-<ds:datastoreItem xmlns:ds="http://schemas.openxmlformats.org/officeDocument/2006/customXml" ds:itemID="{77582B50-6EF7-4CF1-B7A7-FEEAC739BA49}">
+<ds:datastoreItem xmlns:ds="http://schemas.openxmlformats.org/officeDocument/2006/customXml" ds:itemID="{B71204F7-96CD-4AA3-BC27-DA712AE07693}">
   <ds:schemaRefs>
-    <ds:schemaRef ds:uri="34dc7572-b32f-4f93-9661-b1209073c24a"/>
-    <ds:schemaRef ds:uri="6283f531-c8c1-40fe-bb20-fcb69b65cda3"/>
-    <ds:schemaRef ds:uri="http://purl.org/dc/elements/1.1/"/>
-    <ds:schemaRef ds:uri="http://purl.org/dc/terms/"/>
-    <ds:schemaRef ds:uri="http://schemas.microsoft.com/internal/obd"/>
-    <ds:schemaRef ds:uri="http://schemas.microsoft.com/office/2006/documentManagement/types"/>
-    <ds:schemaRef ds:uri="http://schemas.microsoft.com/office/2006/metadata/contentType"/>
-    <ds:schemaRef ds:uri="http://schemas.microsoft.com/office/2006/metadata/properties"/>
-    <ds:schemaRef ds:uri="http://schemas.microsoft.com/office/2006/metadata/properties/metaAttributes"/>
-    <ds:schemaRef ds:uri="http://schemas.microsoft.com/office/infopath/2007/PartnerControls"/>
-    <ds:schemaRef ds:uri="http://schemas.openxmlformats.org/package/2006/metadata/core-properties"/>
-    <ds:schemaRef ds:uri="http://www.w3.org/2001/XMLSchema"/>
+    <ds:schemaRef ds:uri="http://schemas.microsoft.com/sharepoint/v3/contenttype/forms"/>
   </ds:schemaRefs>
 </ds:datastoreItem>
 </file>
@@ -6037,9 +6118,20 @@
 </file>
 
 <file path=customXml/itemProps3.xml><?xml version="1.0" encoding="utf-8"?>
-<ds:datastoreItem xmlns:ds="http://schemas.openxmlformats.org/officeDocument/2006/customXml" ds:itemID="{B71204F7-96CD-4AA3-BC27-DA712AE07693}">
+<ds:datastoreItem xmlns:ds="http://schemas.openxmlformats.org/officeDocument/2006/customXml" ds:itemID="{77582B50-6EF7-4CF1-B7A7-FEEAC739BA49}">
   <ds:schemaRefs>
-    <ds:schemaRef ds:uri="http://schemas.microsoft.com/sharepoint/v3/contenttype/forms"/>
+    <ds:schemaRef ds:uri="34dc7572-b32f-4f93-9661-b1209073c24a"/>
+    <ds:schemaRef ds:uri="6283f531-c8c1-40fe-bb20-fcb69b65cda3"/>
+    <ds:schemaRef ds:uri="http://purl.org/dc/elements/1.1/"/>
+    <ds:schemaRef ds:uri="http://purl.org/dc/terms/"/>
+    <ds:schemaRef ds:uri="http://schemas.microsoft.com/internal/obd"/>
+    <ds:schemaRef ds:uri="http://schemas.microsoft.com/office/2006/documentManagement/types"/>
+    <ds:schemaRef ds:uri="http://schemas.microsoft.com/office/2006/metadata/contentType"/>
+    <ds:schemaRef ds:uri="http://schemas.microsoft.com/office/2006/metadata/properties"/>
+    <ds:schemaRef ds:uri="http://schemas.microsoft.com/office/2006/metadata/properties/metaAttributes"/>
+    <ds:schemaRef ds:uri="http://schemas.microsoft.com/office/infopath/2007/PartnerControls"/>
+    <ds:schemaRef ds:uri="http://schemas.openxmlformats.org/package/2006/metadata/core-properties"/>
+    <ds:schemaRef ds:uri="http://www.w3.org/2001/XMLSchema"/>
   </ds:schemaRefs>
 </ds:datastoreItem>
 </file>
</xml_diff>